<commit_message>
Release v2.3.0: Jenkins indexing, MCP registry polish, 28 tools
Add Jenkins artifact path inference, JUnit dedupe, and cocotb test_artifacts
evidence. Enrich server.json with logo, tags, and docs URL. Align changelogs
and README for the 2.3.0 publish (runs.summary, tests.history, CI formatting).
</commit_message>
<xml_diff>
--- a/conference/slides/sentinel_dv_dvcon2026.pptx
+++ b/conference/slides/sentinel_dv_dvcon2026.pptx
@@ -10,9 +10,11 @@
     <p:sldId id="258" r:id="rId9"/>
     <p:sldId id="259" r:id="rId10"/>
     <p:sldId id="260" r:id="rId11"/>
+    <p:sldId id="267" r:id="rId18"/>
     <p:sldId id="261" r:id="rId12"/>
     <p:sldId id="262" r:id="rId13"/>
     <p:sldId id="263" r:id="rId14"/>
+    <p:sldId id="266" r:id="rId17"/>
     <p:sldId id="264" r:id="rId15"/>
     <p:sldId id="265" r:id="rId16"/>
   </p:sldIdLst>
@@ -3400,7 +3402,7 @@
                   <a:srgbClr val="FFFFFF"/>
                 </a:solidFill>
               </a:rPr>
-              <a:t>26</a:t>
+              <a:t>28</a:t>
             </a:r>
           </a:p>
         </p:txBody>
@@ -3511,7 +3513,7 @@
                   <a:srgbClr val="FFFFFF"/>
                 </a:solidFill>
               </a:rPr>
-              <a:t>3</a:t>
+              <a:t>4</a:t>
             </a:r>
           </a:p>
         </p:txBody>
@@ -3733,7 +3735,7 @@
                   <a:srgbClr val="FFFFFF"/>
                 </a:solidFill>
               </a:rPr>
-              <a:t>MIT</a:t>
+              <a:t>Apache 2.0</a:t>
             </a:r>
           </a:p>
         </p:txBody>
@@ -4059,7 +4061,7 @@
                   <a:srgbClr val="FFFFFF"/>
                 </a:solidFill>
               </a:rPr>
-              <a:t>26 MCP Tools</a:t>
+              <a:t>28 MCP Tools</a:t>
             </a:r>
           </a:p>
         </p:txBody>
@@ -4170,7 +4172,7 @@
                   <a:srgbClr val="FFFFFF"/>
                 </a:solidFill>
               </a:rPr>
-              <a:t>3 Simulators</a:t>
+              <a:t>4 Simulators</a:t>
             </a:r>
           </a:p>
         </p:txBody>
@@ -4204,7 +4206,7 @@
                   <a:srgbClr val="F3F4F6"/>
                 </a:solidFill>
               </a:rPr>
-              <a:t>VCS · Questa · Xcelium</a:t>
+              <a:t>VCS · Questa · Xcelium · Verilator</a:t>
             </a:r>
           </a:p>
         </p:txBody>
@@ -4503,7 +4505,7 @@
                   <a:srgbClr val="FFFFFF"/>
                 </a:solidFill>
               </a:rPr>
-              <a:t>187 Tests</a:t>
+              <a:t>191 Tests</a:t>
             </a:r>
           </a:p>
         </p:txBody>
@@ -4614,7 +4616,7 @@
                   <a:srgbClr val="FFFFFF"/>
                 </a:solidFill>
               </a:rPr>
-              <a:t>MIT License</a:t>
+              <a:t>Apache 2.0</a:t>
             </a:r>
           </a:p>
         </p:txBody>
@@ -4683,6 +4685,274 @@
                 </a:solidFill>
               </a:rPr>
               <a:t>github.com/kiranreddi/sentinel-dv  ·  pip install sentinel-dv  ·  ⭐ Stars Welcome!</a:t>
+            </a:r>
+          </a:p>
+        </p:txBody>
+      </p:sp>
+    </p:spTree>
+  </p:cSld>
+  <p:clrMapOvr>
+    <a:masterClrMapping/>
+  </p:clrMapOvr>
+</p:sld>
+</file>
+
+<file path=ppt/slides/slide11.xml><?xml version="1.0" encoding="utf-8"?>
+<p:sld xmlns:a="http://schemas.openxmlformats.org/drawingml/2006/main" xmlns:p="http://schemas.openxmlformats.org/presentationml/2006/main" xmlns:r="http://schemas.openxmlformats.org/officeDocument/2006/relationships">
+  <p:cSld>
+    <p:spTree>
+      <p:nvGrpSpPr>
+        <p:cNvPr id="1" name=""/>
+        <p:cNvGrpSpPr/>
+        <p:nvPr/>
+      </p:nvGrpSpPr>
+      <p:grpSpPr/>
+      <p:sp>
+        <p:nvSpPr>
+          <p:cNvPr id="2" name="TextBox 1"/>
+          <p:cNvSpPr txBox="1"/>
+          <p:nvPr/>
+        </p:nvSpPr>
+        <p:spPr>
+          <a:xfrm>
+            <a:off x="457200" y="365760"/>
+            <a:ext cx="11274552" cy="914400"/>
+          </a:xfrm>
+          <a:prstGeom prst="rect">
+            <a:avLst/>
+          </a:prstGeom>
+          <a:noFill/>
+        </p:spPr>
+        <p:txBody>
+          <a:bodyPr wrap="square">
+            <a:spAutoFit/>
+          </a:bodyPr>
+          <a:lstStyle/>
+          <a:p>
+            <a:pPr>
+              <a:defRPr sz="3000" b="1"/>
+            </a:pPr>
+            <a:r>
+              <a:t>The Headline: 73% Fewer False Positives</a:t>
+            </a:r>
+          </a:p>
+        </p:txBody>
+      </p:sp>
+      <p:sp>
+        <p:nvSpPr>
+          <p:cNvPr id="3" name="TextBox 2"/>
+          <p:cNvSpPr txBox="1"/>
+          <p:nvPr/>
+        </p:nvSpPr>
+        <p:spPr>
+          <a:xfrm>
+            <a:off x="548640" y="1463040"/>
+            <a:ext cx="11091672" cy="4846320"/>
+          </a:xfrm>
+          <a:prstGeom prst="rect">
+            <a:avLst/>
+          </a:prstGeom>
+          <a:noFill/>
+        </p:spPr>
+        <p:txBody>
+          <a:bodyPr wrap="square">
+            <a:spAutoFit/>
+          </a:bodyPr>
+          <a:lstStyle/>
+          <a:p>
+            <a:pPr>
+              <a:defRPr sz="2000"/>
+            </a:pPr>
+            <a:r>
+              <a:t>VCS appends a count-summary line to every log:  UVM_ERROR :    0</a:t>
+            </a:r>
+          </a:p>
+          <a:p>
+            <a:pPr>
+              <a:defRPr sz="2000"/>
+            </a:pPr>
+            <a:r>
+              <a:t>Parse it naively and every clean run looks like it failed.</a:t>
+            </a:r>
+          </a:p>
+          <a:p>
+            <a:pPr>
+              <a:defRPr sz="2000"/>
+            </a:pPr>
+          </a:p>
+          <a:p>
+            <a:pPr>
+              <a:defRPr sz="2000"/>
+            </a:pPr>
+            <a:r>
+              <a:t>Before count-summary filter:   16,240 "errors" across the VCS corpus</a:t>
+            </a:r>
+          </a:p>
+          <a:p>
+            <a:pPr>
+              <a:defRPr sz="2000"/>
+            </a:pPr>
+            <a:r>
+              <a:t>After count-summary skip:        4,380 genuine failures</a:t>
+            </a:r>
+          </a:p>
+          <a:p>
+            <a:pPr>
+              <a:defRPr sz="2000"/>
+            </a:pPr>
+            <a:r>
+              <a:t>= 73% reduction, matching hand-labeled ground truth.</a:t>
+            </a:r>
+          </a:p>
+          <a:p>
+            <a:pPr>
+              <a:defRPr sz="2000"/>
+            </a:pPr>
+          </a:p>
+          <a:p>
+            <a:pPr>
+              <a:defRPr sz="2000"/>
+            </a:pPr>
+            <a:r>
+              <a:t>One regex is the difference between a usable triage tool and noise.</a:t>
+            </a:r>
+          </a:p>
+        </p:txBody>
+      </p:sp>
+    </p:spTree>
+  </p:cSld>
+  <p:clrMapOvr>
+    <a:masterClrMapping/>
+  </p:clrMapOvr>
+</p:sld>
+</file>
+
+<file path=ppt/slides/slide12.xml><?xml version="1.0" encoding="utf-8"?>
+<p:sld xmlns:a="http://schemas.openxmlformats.org/drawingml/2006/main" xmlns:p="http://schemas.openxmlformats.org/presentationml/2006/main" xmlns:r="http://schemas.openxmlformats.org/officeDocument/2006/relationships">
+  <p:cSld>
+    <p:spTree>
+      <p:nvGrpSpPr>
+        <p:cNvPr id="1" name=""/>
+        <p:cNvGrpSpPr/>
+        <p:nvPr/>
+      </p:nvGrpSpPr>
+      <p:grpSpPr/>
+      <p:sp>
+        <p:nvSpPr>
+          <p:cNvPr id="2" name="TextBox 1"/>
+          <p:cNvSpPr txBox="1"/>
+          <p:nvPr/>
+        </p:nvSpPr>
+        <p:spPr>
+          <a:xfrm>
+            <a:off x="457200" y="365760"/>
+            <a:ext cx="11274552" cy="914400"/>
+          </a:xfrm>
+          <a:prstGeom prst="rect">
+            <a:avLst/>
+          </a:prstGeom>
+          <a:noFill/>
+        </p:spPr>
+        <p:txBody>
+          <a:bodyPr wrap="square">
+            <a:spAutoFit/>
+          </a:bodyPr>
+          <a:lstStyle/>
+          <a:p>
+            <a:pPr>
+              <a:defRPr sz="3000" b="1"/>
+            </a:pPr>
+            <a:r>
+              <a:t>What the Engineer Actually Does</a:t>
+            </a:r>
+          </a:p>
+        </p:txBody>
+      </p:sp>
+      <p:sp>
+        <p:nvSpPr>
+          <p:cNvPr id="3" name="TextBox 2"/>
+          <p:cNvSpPr txBox="1"/>
+          <p:nvPr/>
+        </p:nvSpPr>
+        <p:spPr>
+          <a:xfrm>
+            <a:off x="548640" y="1463040"/>
+            <a:ext cx="11091672" cy="4846320"/>
+          </a:xfrm>
+          <a:prstGeom prst="rect">
+            <a:avLst/>
+          </a:prstGeom>
+          <a:noFill/>
+        </p:spPr>
+        <p:txBody>
+          <a:bodyPr wrap="square">
+            <a:spAutoFit/>
+          </a:bodyPr>
+          <a:lstStyle/>
+          <a:p>
+            <a:pPr>
+              <a:defRPr sz="2000"/>
+            </a:pPr>
+            <a:r>
+              <a:t>Ask Claude:  "Why did axi4_stress_test fail in the latest regression?"</a:t>
+            </a:r>
+          </a:p>
+          <a:p>
+            <a:pPr>
+              <a:defRPr sz="2000"/>
+            </a:pPr>
+          </a:p>
+          <a:p>
+            <a:pPr>
+              <a:defRPr sz="2000"/>
+            </a:pPr>
+            <a:r>
+              <a:t>Behind the scenes — 3 MCP tool calls:</a:t>
+            </a:r>
+          </a:p>
+          <a:p>
+            <a:pPr>
+              <a:defRPr sz="2000"/>
+            </a:pPr>
+            <a:r>
+              <a:t>   1. tests.list      -&gt; locate the failing test and its run</a:t>
+            </a:r>
+          </a:p>
+          <a:p>
+            <a:pPr>
+              <a:defRPr sz="2000"/>
+            </a:pPr>
+            <a:r>
+              <a:t>   2. tests.get       -&gt; log excerpt + failure signature</a:t>
+            </a:r>
+          </a:p>
+          <a:p>
+            <a:pPr>
+              <a:defRPr sz="2000"/>
+            </a:pPr>
+            <a:r>
+              <a:t>   3. runs.cross_sim  -&gt; passes on VCS/Xcelium, fails on Questa</a:t>
+            </a:r>
+          </a:p>
+          <a:p>
+            <a:pPr>
+              <a:defRPr sz="2000"/>
+            </a:pPr>
+          </a:p>
+          <a:p>
+            <a:pPr>
+              <a:defRPr sz="2000"/>
+            </a:pPr>
+            <a:r>
+              <a:t>Answer in seconds: seed-sensitive X-propagation, not an RTL bug.</a:t>
+            </a:r>
+          </a:p>
+          <a:p>
+            <a:pPr>
+              <a:defRPr sz="2000"/>
+            </a:pPr>
+            <a:r>
+              <a:t>No grep, no Verdi, no spreadsheet.</a:t>
             </a:r>
           </a:p>
         </p:txBody>
@@ -4958,7 +5228,7 @@
                   <a:srgbClr val="111827"/>
                 </a:solidFill>
               </a:rPr>
-              <a:t>⚠  UVM failures scattered across VCS, Questa, and Xcelium logs</a:t>
+              <a:t>⚠  UVM failures scattered across VCS, Questa, Xcelium, and Verilator logs</a:t>
             </a:r>
           </a:p>
         </p:txBody>
@@ -6404,7 +6674,7 @@
                   <a:srgbClr val="FFFFFF"/>
                 </a:solidFill>
               </a:rPr>
-              <a:t>26 MCP Tools — Six Categories</a:t>
+              <a:t>28 MCP Tools — Six Categories</a:t>
             </a:r>
           </a:p>
         </p:txBody>
@@ -6517,9 +6787,9 @@
                   <a:srgbClr val="111827"/>
                 </a:solidFill>
               </a:rPr>
-              <a:t>runs.list · runs.get
-runs.diff · runs.submit
-runs.cross_sim</a:t>
+              <a:t>runs.list · runs.get · runs.summary
+runs.diff · runs.cross_sim★
+runs.submit† (dry-run cmd)</a:t>
             </a:r>
           </a:p>
         </p:txBody>
@@ -6632,9 +6902,9 @@
                   <a:srgbClr val="111827"/>
                 </a:solidFill>
               </a:rPr>
-              <a:t>tests.list · tests.get
-tests.topology
-tests.replay · tests.cluster</a:t>
+              <a:t>tests.list · tests.get · tests.history
+tests.topology · tests.cluster★
+tests.replay† (dry-run cmd)</a:t>
             </a:r>
           </a:p>
         </p:txBody>
@@ -7058,7 +7328,7 @@
                   <a:srgbClr val="0694A2"/>
                 </a:solidFill>
               </a:rPr>
-              <a:t>🌊 Live Simulation</a:t>
+              <a:t>🌊 Live Run &amp; Waveforms</a:t>
             </a:r>
           </a:p>
         </p:txBody>
@@ -7092,9 +7362,9 @@
                   <a:srgbClr val="111827"/>
                 </a:solidFill>
               </a:rPr>
-              <a:t>wave.signals
-wave.summary
-sim.status</a:t>
+              <a:t>sim.status (live_status.json)
+wave.signals
+wave.summary</a:t>
             </a:r>
           </a:p>
         </p:txBody>
@@ -8848,7 +9118,7 @@
                   <a:srgbClr val="FFFFFF"/>
                 </a:solidFill>
               </a:rPr>
-              <a:t>0/26</a:t>
+              <a:t>22/28</a:t>
             </a:r>
           </a:p>
         </p:txBody>
@@ -8882,8 +9152,8 @@
                   <a:srgbClr val="FFFFFF"/>
                 </a:solidFill>
               </a:rPr>
-              <a:t>Tool
-Failures</a:t>
+              <a:t>Tools Validated
+0 wrong outputs</a:t>
             </a:r>
           </a:p>
         </p:txBody>
@@ -8960,7 +9230,7 @@
                   <a:srgbClr val="FFFFFF"/>
                 </a:solidFill>
               </a:rPr>
-              <a:t>187</a:t>
+              <a:t>191</a:t>
             </a:r>
           </a:p>
         </p:txBody>

</xml_diff>